<commit_message>
Refine Huawei PPT skill guidance and template assets
</commit_message>
<xml_diff>
--- a/template/hw_template.pptx
+++ b/template/hw_template.pptx
@@ -3,9 +3,9 @@
 <p:presentation xmlns:a="http://schemas.openxmlformats.org/drawingml/2006/main" xmlns:r="http://schemas.openxmlformats.org/officeDocument/2006/relationships" xmlns:p="http://schemas.openxmlformats.org/presentationml/2006/main">
   <p:sldMasterIdLst>
     <p:sldMasterId id="2147483648" r:id="rId1"/>
-    <p:sldMasterId id="2147483653" r:id="rId3"/>
-    <p:sldMasterId id="2147483655" r:id="rId4"/>
-    <p:sldMasterId id="2147483657" r:id="rId5"/>
+    <p:sldMasterId id="2147483650" r:id="rId3"/>
+    <p:sldMasterId id="2147483652" r:id="rId4"/>
+    <p:sldMasterId id="2147483654" r:id="rId5"/>
   </p:sldMasterIdLst>
   <p:notesMasterIdLst>
     <p:notesMasterId r:id="rId10"/>
@@ -943,569 +943,6 @@
 </file>
 
 <file path=ppt/slideLayouts/slideLayout2.xml><?xml version="1.0" encoding="utf-8"?>
-<p:sldLayout xmlns:a="http://schemas.openxmlformats.org/drawingml/2006/main" xmlns:r="http://schemas.openxmlformats.org/officeDocument/2006/relationships" xmlns:p="http://schemas.openxmlformats.org/presentationml/2006/main" preserve="1" userDrawn="1">
-  <p:cSld name="智能">
-    <p:spTree>
-      <p:nvGrpSpPr>
-        <p:cNvPr id="1" name=""/>
-        <p:cNvGrpSpPr/>
-        <p:nvPr/>
-      </p:nvGrpSpPr>
-      <p:grpSpPr>
-        <a:xfrm>
-          <a:off x="0" y="0"/>
-          <a:ext cx="0" cy="0"/>
-          <a:chOff x="0" y="0"/>
-          <a:chExt cx="0" cy="0"/>
-        </a:xfrm>
-      </p:grpSpPr>
-      <p:pic>
-        <p:nvPicPr>
-          <p:cNvPr id="14" name="图片 13"/>
-          <p:cNvPicPr>
-            <a:picLocks noChangeAspect="1"/>
-          </p:cNvPicPr>
-          <p:nvPr userDrawn="1"/>
-        </p:nvPicPr>
-        <p:blipFill rotWithShape="1">
-          <a:blip r:embed="rId2" cstate="screen"/>
-          <a:srcRect/>
-          <a:stretch>
-            <a:fillRect/>
-          </a:stretch>
-        </p:blipFill>
-        <p:spPr>
-          <a:xfrm>
-            <a:off x="1" y="0"/>
-            <a:ext cx="12196763" cy="5602265"/>
-          </a:xfrm>
-          <a:prstGeom prst="rect">
-            <a:avLst/>
-          </a:prstGeom>
-        </p:spPr>
-      </p:pic>
-      <p:sp>
-        <p:nvSpPr>
-          <p:cNvPr id="18" name="L 形 17"/>
-          <p:cNvSpPr/>
-          <p:nvPr userDrawn="1"/>
-        </p:nvSpPr>
-        <p:spPr>
-          <a:xfrm rot="5400000">
-            <a:off x="5824025" y="2568635"/>
-            <a:ext cx="701032" cy="717936"/>
-          </a:xfrm>
-          <a:prstGeom prst="corner">
-            <a:avLst>
-              <a:gd name="adj1" fmla="val 3243"/>
-              <a:gd name="adj2" fmla="val 3048"/>
-            </a:avLst>
-          </a:prstGeom>
-          <a:solidFill>
-            <a:srgbClr val="C7000B"/>
-          </a:solidFill>
-          <a:ln>
-            <a:noFill/>
-          </a:ln>
-        </p:spPr>
-        <p:style>
-          <a:lnRef idx="2">
-            <a:schemeClr val="accent1">
-              <a:shade val="50000"/>
-            </a:schemeClr>
-          </a:lnRef>
-          <a:fillRef idx="1">
-            <a:schemeClr val="accent1"/>
-          </a:fillRef>
-          <a:effectRef idx="0">
-            <a:schemeClr val="accent1"/>
-          </a:effectRef>
-          <a:fontRef idx="minor">
-            <a:schemeClr val="lt1"/>
-          </a:fontRef>
-        </p:style>
-        <p:txBody>
-          <a:bodyPr rtlCol="0" anchor="ctr"/>
-          <a:lstStyle/>
-          <a:p>
-            <a:pPr algn="ctr"/>
-            <a:endParaRPr kumimoji="1" lang="zh-CN" altLang="en-US" sz="900"/>
-          </a:p>
-        </p:txBody>
-      </p:sp>
-      <p:sp>
-        <p:nvSpPr>
-          <p:cNvPr id="8" name="Title 1"/>
-          <p:cNvSpPr>
-            <a:spLocks noGrp="1"/>
-          </p:cNvSpPr>
-          <p:nvPr>
-            <p:ph type="ctrTitle" hasCustomPrompt="1"/>
-          </p:nvPr>
-        </p:nvSpPr>
-        <p:spPr>
-          <a:xfrm>
-            <a:off x="898996" y="907092"/>
-            <a:ext cx="6559809" cy="690255"/>
-          </a:xfrm>
-          <a:prstGeom prst="rect">
-            <a:avLst/>
-          </a:prstGeom>
-        </p:spPr>
-        <p:txBody>
-          <a:bodyPr lIns="0" tIns="0" rIns="0" bIns="0" anchor="t">
-            <a:normAutofit/>
-          </a:bodyPr>
-          <a:lstStyle>
-            <a:lvl1pPr algn="l">
-              <a:defRPr sz="3200" b="0" i="0">
-                <a:solidFill>
-                  <a:schemeClr val="tx1"/>
-                </a:solidFill>
-                <a:latin typeface="微软雅黑" panose="020B0503020204020204" pitchFamily="34" charset="-122"/>
-                <a:ea typeface="微软雅黑" panose="020B0503020204020204" pitchFamily="34" charset="-122"/>
-              </a:defRPr>
-            </a:lvl1pPr>
-          </a:lstStyle>
-          <a:p>
-            <a:r>
-              <a:rPr lang="zh-CN" altLang="en-US" dirty="0"/>
-              <a:t>单击此处添加标题</a:t>
-            </a:r>
-            <a:endParaRPr lang="en-US" dirty="0"/>
-          </a:p>
-        </p:txBody>
-      </p:sp>
-      <p:sp>
-        <p:nvSpPr>
-          <p:cNvPr id="5" name="Text Placeholder 5"/>
-          <p:cNvSpPr>
-            <a:spLocks noGrp="1"/>
-          </p:cNvSpPr>
-          <p:nvPr>
-            <p:ph type="body" sz="quarter" idx="10" hasCustomPrompt="1"/>
-          </p:nvPr>
-        </p:nvSpPr>
-        <p:spPr>
-          <a:xfrm>
-            <a:off x="929260" y="1949372"/>
-            <a:ext cx="6535842" cy="643926"/>
-          </a:xfrm>
-        </p:spPr>
-        <p:txBody>
-          <a:bodyPr/>
-          <a:lstStyle>
-            <a:lvl1pPr>
-              <a:defRPr sz="1400">
-                <a:solidFill>
-                  <a:schemeClr val="tx1"/>
-                </a:solidFill>
-              </a:defRPr>
-            </a:lvl1pPr>
-          </a:lstStyle>
-          <a:p>
-            <a:pPr lvl="0"/>
-            <a:r>
-              <a:rPr lang="zh-CN" altLang="en-US" dirty="0"/>
-              <a:t>单击此处添加文本</a:t>
-            </a:r>
-            <a:endParaRPr lang="en-US" dirty="0"/>
-          </a:p>
-        </p:txBody>
-      </p:sp>
-    </p:spTree>
-  </p:cSld>
-  <p:clrMapOvr>
-    <a:masterClrMapping/>
-  </p:clrMapOvr>
-</p:sldLayout>
-</file>
-
-<file path=ppt/slideLayouts/slideLayout3.xml><?xml version="1.0" encoding="utf-8"?>
-<p:sldLayout xmlns:a="http://schemas.openxmlformats.org/drawingml/2006/main" xmlns:r="http://schemas.openxmlformats.org/officeDocument/2006/relationships" xmlns:p="http://schemas.openxmlformats.org/presentationml/2006/main" preserve="1" userDrawn="1">
-  <p:cSld name="攀登">
-    <p:spTree>
-      <p:nvGrpSpPr>
-        <p:cNvPr id="1" name=""/>
-        <p:cNvGrpSpPr/>
-        <p:nvPr/>
-      </p:nvGrpSpPr>
-      <p:grpSpPr>
-        <a:xfrm>
-          <a:off x="0" y="0"/>
-          <a:ext cx="0" cy="0"/>
-          <a:chOff x="0" y="0"/>
-          <a:chExt cx="0" cy="0"/>
-        </a:xfrm>
-      </p:grpSpPr>
-      <p:pic>
-        <p:nvPicPr>
-          <p:cNvPr id="4" name="图片 3"/>
-          <p:cNvPicPr>
-            <a:picLocks noChangeAspect="1"/>
-          </p:cNvPicPr>
-          <p:nvPr userDrawn="1"/>
-        </p:nvPicPr>
-        <p:blipFill rotWithShape="1">
-          <a:blip r:embed="rId2">
-            <a:extLst>
-              <a:ext uri="{28A0092B-C50C-407E-A947-70E740481C1C}">
-                <a14:useLocalDpi xmlns:a14="http://schemas.microsoft.com/office/drawing/2010/main" val="0"/>
-              </a:ext>
-            </a:extLst>
-          </a:blip>
-          <a:srcRect t="13825" r="2034" b="5607"/>
-          <a:stretch>
-            <a:fillRect/>
-          </a:stretch>
-        </p:blipFill>
-        <p:spPr>
-          <a:xfrm>
-            <a:off x="1" y="-36206"/>
-            <a:ext cx="12196763" cy="5638471"/>
-          </a:xfrm>
-          <a:prstGeom prst="rect">
-            <a:avLst/>
-          </a:prstGeom>
-        </p:spPr>
-      </p:pic>
-      <p:sp>
-        <p:nvSpPr>
-          <p:cNvPr id="2" name="Title 1"/>
-          <p:cNvSpPr>
-            <a:spLocks noGrp="1"/>
-          </p:cNvSpPr>
-          <p:nvPr>
-            <p:ph type="ctrTitle" hasCustomPrompt="1"/>
-          </p:nvPr>
-        </p:nvSpPr>
-        <p:spPr>
-          <a:xfrm>
-            <a:off x="898996" y="907092"/>
-            <a:ext cx="6559809" cy="690255"/>
-          </a:xfrm>
-          <a:prstGeom prst="rect">
-            <a:avLst/>
-          </a:prstGeom>
-        </p:spPr>
-        <p:txBody>
-          <a:bodyPr lIns="0" tIns="0" rIns="0" bIns="0" anchor="t">
-            <a:normAutofit/>
-          </a:bodyPr>
-          <a:lstStyle>
-            <a:lvl1pPr algn="l">
-              <a:defRPr sz="3200" b="0" i="0">
-                <a:solidFill>
-                  <a:schemeClr val="tx1"/>
-                </a:solidFill>
-                <a:latin typeface="微软雅黑" panose="020B0503020204020204" pitchFamily="34" charset="-122"/>
-                <a:ea typeface="微软雅黑" panose="020B0503020204020204" pitchFamily="34" charset="-122"/>
-              </a:defRPr>
-            </a:lvl1pPr>
-          </a:lstStyle>
-          <a:p>
-            <a:r>
-              <a:rPr lang="zh-CN" altLang="en-US" dirty="0"/>
-              <a:t>单击此处添加标题</a:t>
-            </a:r>
-            <a:endParaRPr lang="en-US" dirty="0"/>
-          </a:p>
-        </p:txBody>
-      </p:sp>
-      <p:sp>
-        <p:nvSpPr>
-          <p:cNvPr id="8" name="L 形 7"/>
-          <p:cNvSpPr/>
-          <p:nvPr userDrawn="1"/>
-        </p:nvSpPr>
-        <p:spPr>
-          <a:xfrm rot="5400000">
-            <a:off x="7929967" y="1657555"/>
-            <a:ext cx="701032" cy="717936"/>
-          </a:xfrm>
-          <a:prstGeom prst="corner">
-            <a:avLst>
-              <a:gd name="adj1" fmla="val 3243"/>
-              <a:gd name="adj2" fmla="val 3048"/>
-            </a:avLst>
-          </a:prstGeom>
-          <a:solidFill>
-            <a:srgbClr val="C7000B"/>
-          </a:solidFill>
-          <a:ln>
-            <a:noFill/>
-          </a:ln>
-        </p:spPr>
-        <p:style>
-          <a:lnRef idx="2">
-            <a:schemeClr val="accent1">
-              <a:shade val="50000"/>
-            </a:schemeClr>
-          </a:lnRef>
-          <a:fillRef idx="1">
-            <a:schemeClr val="accent1"/>
-          </a:fillRef>
-          <a:effectRef idx="0">
-            <a:schemeClr val="accent1"/>
-          </a:effectRef>
-          <a:fontRef idx="minor">
-            <a:schemeClr val="lt1"/>
-          </a:fontRef>
-        </p:style>
-        <p:txBody>
-          <a:bodyPr rtlCol="0" anchor="ctr"/>
-          <a:lstStyle/>
-          <a:p>
-            <a:pPr algn="ctr"/>
-            <a:endParaRPr kumimoji="1" lang="zh-CN" altLang="en-US" sz="900"/>
-          </a:p>
-        </p:txBody>
-      </p:sp>
-      <p:sp>
-        <p:nvSpPr>
-          <p:cNvPr id="5" name="Text Placeholder 5"/>
-          <p:cNvSpPr>
-            <a:spLocks noGrp="1"/>
-          </p:cNvSpPr>
-          <p:nvPr>
-            <p:ph type="body" sz="quarter" idx="10" hasCustomPrompt="1"/>
-          </p:nvPr>
-        </p:nvSpPr>
-        <p:spPr>
-          <a:xfrm>
-            <a:off x="929260" y="1949372"/>
-            <a:ext cx="6535842" cy="643926"/>
-          </a:xfrm>
-        </p:spPr>
-        <p:txBody>
-          <a:bodyPr/>
-          <a:lstStyle>
-            <a:lvl1pPr>
-              <a:defRPr sz="1400">
-                <a:solidFill>
-                  <a:schemeClr val="tx1"/>
-                </a:solidFill>
-              </a:defRPr>
-            </a:lvl1pPr>
-          </a:lstStyle>
-          <a:p>
-            <a:pPr lvl="0"/>
-            <a:r>
-              <a:rPr lang="zh-CN" altLang="en-US" dirty="0"/>
-              <a:t>单击此处添加文本</a:t>
-            </a:r>
-            <a:endParaRPr lang="en-US" dirty="0"/>
-          </a:p>
-        </p:txBody>
-      </p:sp>
-    </p:spTree>
-  </p:cSld>
-  <p:clrMapOvr>
-    <a:masterClrMapping/>
-  </p:clrMapOvr>
-  <p:timing>
-    <p:tnLst>
-      <p:par>
-        <p:cTn id="1" dur="indefinite" restart="never" nodeType="tmRoot"/>
-      </p:par>
-    </p:tnLst>
-  </p:timing>
-</p:sldLayout>
-</file>
-
-<file path=ppt/slideLayouts/slideLayout4.xml><?xml version="1.0" encoding="utf-8"?>
-<p:sldLayout xmlns:a="http://schemas.openxmlformats.org/drawingml/2006/main" xmlns:r="http://schemas.openxmlformats.org/officeDocument/2006/relationships" xmlns:p="http://schemas.openxmlformats.org/presentationml/2006/main" preserve="1" userDrawn="1">
-  <p:cSld name="灯塔">
-    <p:spTree>
-      <p:nvGrpSpPr>
-        <p:cNvPr id="1" name=""/>
-        <p:cNvGrpSpPr/>
-        <p:nvPr/>
-      </p:nvGrpSpPr>
-      <p:grpSpPr>
-        <a:xfrm>
-          <a:off x="0" y="0"/>
-          <a:ext cx="0" cy="0"/>
-          <a:chOff x="0" y="0"/>
-          <a:chExt cx="0" cy="0"/>
-        </a:xfrm>
-      </p:grpSpPr>
-      <p:pic>
-        <p:nvPicPr>
-          <p:cNvPr id="3" name="图片 2"/>
-          <p:cNvPicPr>
-            <a:picLocks noChangeAspect="1"/>
-          </p:cNvPicPr>
-          <p:nvPr userDrawn="1"/>
-        </p:nvPicPr>
-        <p:blipFill rotWithShape="1">
-          <a:blip r:embed="rId2" cstate="print">
-            <a:extLst>
-              <a:ext uri="{28A0092B-C50C-407E-A947-70E740481C1C}">
-                <a14:useLocalDpi xmlns:a14="http://schemas.microsoft.com/office/drawing/2010/main" val="0"/>
-              </a:ext>
-            </a:extLst>
-          </a:blip>
-          <a:srcRect l="1538" t="7030" b="11599"/>
-          <a:stretch>
-            <a:fillRect/>
-          </a:stretch>
-        </p:blipFill>
-        <p:spPr>
-          <a:xfrm>
-            <a:off x="0" y="0"/>
-            <a:ext cx="12196763" cy="5602265"/>
-          </a:xfrm>
-          <a:prstGeom prst="rect">
-            <a:avLst/>
-          </a:prstGeom>
-        </p:spPr>
-      </p:pic>
-      <p:sp>
-        <p:nvSpPr>
-          <p:cNvPr id="13" name="L 形 12"/>
-          <p:cNvSpPr/>
-          <p:nvPr userDrawn="1"/>
-        </p:nvSpPr>
-        <p:spPr>
-          <a:xfrm rot="5400000">
-            <a:off x="5945516" y="2323519"/>
-            <a:ext cx="701032" cy="717936"/>
-          </a:xfrm>
-          <a:prstGeom prst="corner">
-            <a:avLst>
-              <a:gd name="adj1" fmla="val 3243"/>
-              <a:gd name="adj2" fmla="val 3048"/>
-            </a:avLst>
-          </a:prstGeom>
-          <a:solidFill>
-            <a:srgbClr val="C7000B"/>
-          </a:solidFill>
-          <a:ln>
-            <a:noFill/>
-          </a:ln>
-        </p:spPr>
-        <p:style>
-          <a:lnRef idx="2">
-            <a:schemeClr val="accent1">
-              <a:shade val="50000"/>
-            </a:schemeClr>
-          </a:lnRef>
-          <a:fillRef idx="1">
-            <a:schemeClr val="accent1"/>
-          </a:fillRef>
-          <a:effectRef idx="0">
-            <a:schemeClr val="accent1"/>
-          </a:effectRef>
-          <a:fontRef idx="minor">
-            <a:schemeClr val="lt1"/>
-          </a:fontRef>
-        </p:style>
-        <p:txBody>
-          <a:bodyPr rtlCol="0" anchor="ctr"/>
-          <a:lstStyle/>
-          <a:p>
-            <a:pPr algn="ctr"/>
-            <a:endParaRPr kumimoji="1" lang="zh-CN" altLang="en-US" sz="900"/>
-          </a:p>
-        </p:txBody>
-      </p:sp>
-      <p:sp>
-        <p:nvSpPr>
-          <p:cNvPr id="11" name="Title 1"/>
-          <p:cNvSpPr>
-            <a:spLocks noGrp="1"/>
-          </p:cNvSpPr>
-          <p:nvPr>
-            <p:ph type="ctrTitle" hasCustomPrompt="1"/>
-          </p:nvPr>
-        </p:nvSpPr>
-        <p:spPr>
-          <a:xfrm>
-            <a:off x="898996" y="907092"/>
-            <a:ext cx="6559809" cy="690255"/>
-          </a:xfrm>
-          <a:prstGeom prst="rect">
-            <a:avLst/>
-          </a:prstGeom>
-        </p:spPr>
-        <p:txBody>
-          <a:bodyPr lIns="0" tIns="0" rIns="0" bIns="0" anchor="t">
-            <a:normAutofit/>
-          </a:bodyPr>
-          <a:lstStyle>
-            <a:lvl1pPr algn="l">
-              <a:defRPr sz="3200" b="0" i="0">
-                <a:solidFill>
-                  <a:schemeClr val="tx1"/>
-                </a:solidFill>
-                <a:latin typeface="微软雅黑" panose="020B0503020204020204" pitchFamily="34" charset="-122"/>
-                <a:ea typeface="微软雅黑" panose="020B0503020204020204" pitchFamily="34" charset="-122"/>
-              </a:defRPr>
-            </a:lvl1pPr>
-          </a:lstStyle>
-          <a:p>
-            <a:r>
-              <a:rPr lang="zh-CN" altLang="en-US" dirty="0"/>
-              <a:t>单击此处添加标题</a:t>
-            </a:r>
-            <a:endParaRPr lang="en-US" dirty="0"/>
-          </a:p>
-        </p:txBody>
-      </p:sp>
-      <p:sp>
-        <p:nvSpPr>
-          <p:cNvPr id="5" name="Text Placeholder 5"/>
-          <p:cNvSpPr>
-            <a:spLocks noGrp="1"/>
-          </p:cNvSpPr>
-          <p:nvPr>
-            <p:ph type="body" sz="quarter" idx="10" hasCustomPrompt="1"/>
-          </p:nvPr>
-        </p:nvSpPr>
-        <p:spPr>
-          <a:xfrm>
-            <a:off x="929260" y="1949372"/>
-            <a:ext cx="6535842" cy="643926"/>
-          </a:xfrm>
-        </p:spPr>
-        <p:txBody>
-          <a:bodyPr/>
-          <a:lstStyle>
-            <a:lvl1pPr>
-              <a:defRPr sz="1400">
-                <a:solidFill>
-                  <a:schemeClr val="tx1"/>
-                </a:solidFill>
-              </a:defRPr>
-            </a:lvl1pPr>
-          </a:lstStyle>
-          <a:p>
-            <a:pPr lvl="0"/>
-            <a:r>
-              <a:rPr lang="zh-CN" altLang="en-US" dirty="0"/>
-              <a:t>单击此处添加文本</a:t>
-            </a:r>
-            <a:endParaRPr lang="en-US" dirty="0"/>
-          </a:p>
-        </p:txBody>
-      </p:sp>
-    </p:spTree>
-  </p:cSld>
-  <p:clrMapOvr>
-    <a:masterClrMapping/>
-  </p:clrMapOvr>
-  <p:timing>
-    <p:tnLst>
-      <p:par>
-        <p:cTn id="1" dur="indefinite" restart="never" nodeType="tmRoot"/>
-      </p:par>
-    </p:tnLst>
-  </p:timing>
-</p:sldLayout>
-</file>
-
-<file path=ppt/slideLayouts/slideLayout5.xml><?xml version="1.0" encoding="utf-8"?>
 <p:sldLayout xmlns:a="http://schemas.openxmlformats.org/drawingml/2006/main" xmlns:r="http://schemas.openxmlformats.org/officeDocument/2006/relationships" xmlns:p="http://schemas.openxmlformats.org/presentationml/2006/main" userDrawn="1">
   <p:cSld name="1_Contents page">
     <p:bg>
@@ -1694,7 +1131,7 @@
 </p:sldLayout>
 </file>
 
-<file path=ppt/slideLayouts/slideLayout6.xml><?xml version="1.0" encoding="utf-8"?>
+<file path=ppt/slideLayouts/slideLayout3.xml><?xml version="1.0" encoding="utf-8"?>
 <p:sldLayout xmlns:a="http://schemas.openxmlformats.org/drawingml/2006/main" xmlns:r="http://schemas.openxmlformats.org/officeDocument/2006/relationships" xmlns:p="http://schemas.openxmlformats.org/presentationml/2006/main" userDrawn="1">
   <p:cSld name="1_Chinese text page">
     <p:spTree>
@@ -1887,7 +1324,7 @@
 </p:sldLayout>
 </file>
 
-<file path=ppt/slideLayouts/slideLayout7.xml><?xml version="1.0" encoding="utf-8"?>
+<file path=ppt/slideLayouts/slideLayout4.xml><?xml version="1.0" encoding="utf-8"?>
 <p:sldLayout xmlns:a="http://schemas.openxmlformats.org/drawingml/2006/main" xmlns:r="http://schemas.openxmlformats.org/officeDocument/2006/relationships" xmlns:p="http://schemas.openxmlformats.org/presentationml/2006/main" preserve="1" userDrawn="1">
   <p:cSld name="End page">
     <p:bg>
@@ -2031,7 +1468,7 @@
           <p:nvPr userDrawn="1"/>
         </p:nvPicPr>
         <p:blipFill>
-          <a:blip r:embed="rId5" cstate="print">
+          <a:blip r:embed="rId2" cstate="print">
             <a:extLst>
               <a:ext uri="{28A0092B-C50C-407E-A947-70E740481C1C}">
                 <a14:useLocalDpi xmlns:a14="http://schemas.microsoft.com/office/drawing/2010/main" val="0"/>
@@ -2057,9 +1494,6 @@
   <p:clrMap bg1="lt1" tx1="dk1" bg2="lt2" tx2="dk2" accent1="accent1" accent2="accent2" accent3="accent3" accent4="accent4" accent5="accent5" accent6="accent6" hlink="hlink" folHlink="folHlink"/>
   <p:sldLayoutIdLst>
     <p:sldLayoutId id="2147483649" r:id="rId1"/>
-    <p:sldLayoutId id="2147483650" r:id="rId2"/>
-    <p:sldLayoutId id="2147483651" r:id="rId3"/>
-    <p:sldLayoutId id="2147483652" r:id="rId4"/>
   </p:sldLayoutIdLst>
   <p:timing>
     <p:tnLst>
@@ -2381,7 +1815,7 @@
   </p:cSld>
   <p:clrMap bg1="lt1" tx1="dk1" bg2="lt2" tx2="dk2" accent1="accent1" accent2="accent2" accent3="accent3" accent4="accent4" accent5="accent5" accent6="accent6" hlink="hlink" folHlink="folHlink"/>
   <p:sldLayoutIdLst>
-    <p:sldLayoutId id="2147483654" r:id="rId1"/>
+    <p:sldLayoutId id="2147483651" r:id="rId1"/>
   </p:sldLayoutIdLst>
   <p:hf hdr="0" ftr="0" dt="0"/>
   <p:txStyles>
@@ -4575,7 +4009,7 @@
   </p:cSld>
   <p:clrMap bg1="lt1" tx1="dk1" bg2="lt2" tx2="dk2" accent1="accent1" accent2="accent2" accent3="accent3" accent4="accent4" accent5="accent5" accent6="accent6" hlink="hlink" folHlink="folHlink"/>
   <p:sldLayoutIdLst>
-    <p:sldLayoutId id="2147483656" r:id="rId1"/>
+    <p:sldLayoutId id="2147483653" r:id="rId1"/>
   </p:sldLayoutIdLst>
   <p:timing>
     <p:tnLst>
@@ -5868,7 +5302,7 @@
   </p:cSld>
   <p:clrMap bg1="lt1" tx1="dk1" bg2="lt2" tx2="dk2" accent1="accent1" accent2="accent2" accent3="accent3" accent4="accent4" accent5="accent5" accent6="accent6" hlink="hlink" folHlink="folHlink"/>
   <p:sldLayoutIdLst>
-    <p:sldLayoutId id="2147483658" r:id="rId1"/>
+    <p:sldLayoutId id="2147483655" r:id="rId1"/>
   </p:sldLayoutIdLst>
   <p:hf hdr="0" ftr="0" dt="0"/>
   <p:txStyles>

</xml_diff>

<commit_message>
Update Huawei PPT skill and template assets
</commit_message>
<xml_diff>
--- a/template/hw_template.pptx
+++ b/template/hw_template.pptx
@@ -3,9 +3,9 @@
 <p:presentation xmlns:a="http://schemas.openxmlformats.org/drawingml/2006/main" xmlns:r="http://schemas.openxmlformats.org/officeDocument/2006/relationships" xmlns:p="http://schemas.openxmlformats.org/presentationml/2006/main">
   <p:sldMasterIdLst>
     <p:sldMasterId id="2147483648" r:id="rId1"/>
-    <p:sldMasterId id="2147483650" r:id="rId3"/>
-    <p:sldMasterId id="2147483652" r:id="rId4"/>
-    <p:sldMasterId id="2147483654" r:id="rId5"/>
+    <p:sldMasterId id="2147483653" r:id="rId3"/>
+    <p:sldMasterId id="2147483655" r:id="rId4"/>
+    <p:sldMasterId id="2147483657" r:id="rId5"/>
   </p:sldMasterIdLst>
   <p:notesMasterIdLst>
     <p:notesMasterId r:id="rId10"/>
@@ -943,6 +943,569 @@
 </file>
 
 <file path=ppt/slideLayouts/slideLayout2.xml><?xml version="1.0" encoding="utf-8"?>
+<p:sldLayout xmlns:a="http://schemas.openxmlformats.org/drawingml/2006/main" xmlns:r="http://schemas.openxmlformats.org/officeDocument/2006/relationships" xmlns:p="http://schemas.openxmlformats.org/presentationml/2006/main" preserve="1" userDrawn="1">
+  <p:cSld name="智能">
+    <p:spTree>
+      <p:nvGrpSpPr>
+        <p:cNvPr id="1" name=""/>
+        <p:cNvGrpSpPr/>
+        <p:nvPr/>
+      </p:nvGrpSpPr>
+      <p:grpSpPr>
+        <a:xfrm>
+          <a:off x="0" y="0"/>
+          <a:ext cx="0" cy="0"/>
+          <a:chOff x="0" y="0"/>
+          <a:chExt cx="0" cy="0"/>
+        </a:xfrm>
+      </p:grpSpPr>
+      <p:pic>
+        <p:nvPicPr>
+          <p:cNvPr id="14" name="图片 13"/>
+          <p:cNvPicPr>
+            <a:picLocks noChangeAspect="1"/>
+          </p:cNvPicPr>
+          <p:nvPr userDrawn="1"/>
+        </p:nvPicPr>
+        <p:blipFill rotWithShape="1">
+          <a:blip r:embed="rId2" cstate="screen"/>
+          <a:srcRect/>
+          <a:stretch>
+            <a:fillRect/>
+          </a:stretch>
+        </p:blipFill>
+        <p:spPr>
+          <a:xfrm>
+            <a:off x="1" y="0"/>
+            <a:ext cx="12196763" cy="5602265"/>
+          </a:xfrm>
+          <a:prstGeom prst="rect">
+            <a:avLst/>
+          </a:prstGeom>
+        </p:spPr>
+      </p:pic>
+      <p:sp>
+        <p:nvSpPr>
+          <p:cNvPr id="18" name="L 形 17"/>
+          <p:cNvSpPr/>
+          <p:nvPr userDrawn="1"/>
+        </p:nvSpPr>
+        <p:spPr>
+          <a:xfrm rot="5400000">
+            <a:off x="5824025" y="2568635"/>
+            <a:ext cx="701032" cy="717936"/>
+          </a:xfrm>
+          <a:prstGeom prst="corner">
+            <a:avLst>
+              <a:gd name="adj1" fmla="val 3243"/>
+              <a:gd name="adj2" fmla="val 3048"/>
+            </a:avLst>
+          </a:prstGeom>
+          <a:solidFill>
+            <a:srgbClr val="C7000B"/>
+          </a:solidFill>
+          <a:ln>
+            <a:noFill/>
+          </a:ln>
+        </p:spPr>
+        <p:style>
+          <a:lnRef idx="2">
+            <a:schemeClr val="accent1">
+              <a:shade val="50000"/>
+            </a:schemeClr>
+          </a:lnRef>
+          <a:fillRef idx="1">
+            <a:schemeClr val="accent1"/>
+          </a:fillRef>
+          <a:effectRef idx="0">
+            <a:schemeClr val="accent1"/>
+          </a:effectRef>
+          <a:fontRef idx="minor">
+            <a:schemeClr val="lt1"/>
+          </a:fontRef>
+        </p:style>
+        <p:txBody>
+          <a:bodyPr rtlCol="0" anchor="ctr"/>
+          <a:lstStyle/>
+          <a:p>
+            <a:pPr algn="ctr"/>
+            <a:endParaRPr kumimoji="1" lang="zh-CN" altLang="en-US" sz="900"/>
+          </a:p>
+        </p:txBody>
+      </p:sp>
+      <p:sp>
+        <p:nvSpPr>
+          <p:cNvPr id="8" name="Title 1"/>
+          <p:cNvSpPr>
+            <a:spLocks noGrp="1"/>
+          </p:cNvSpPr>
+          <p:nvPr>
+            <p:ph type="ctrTitle" hasCustomPrompt="1"/>
+          </p:nvPr>
+        </p:nvSpPr>
+        <p:spPr>
+          <a:xfrm>
+            <a:off x="898996" y="907092"/>
+            <a:ext cx="6559809" cy="690255"/>
+          </a:xfrm>
+          <a:prstGeom prst="rect">
+            <a:avLst/>
+          </a:prstGeom>
+        </p:spPr>
+        <p:txBody>
+          <a:bodyPr lIns="0" tIns="0" rIns="0" bIns="0" anchor="t">
+            <a:normAutofit/>
+          </a:bodyPr>
+          <a:lstStyle>
+            <a:lvl1pPr algn="l">
+              <a:defRPr sz="3200" b="0" i="0">
+                <a:solidFill>
+                  <a:schemeClr val="tx1"/>
+                </a:solidFill>
+                <a:latin typeface="微软雅黑" panose="020B0503020204020204" pitchFamily="34" charset="-122"/>
+                <a:ea typeface="微软雅黑" panose="020B0503020204020204" pitchFamily="34" charset="-122"/>
+              </a:defRPr>
+            </a:lvl1pPr>
+          </a:lstStyle>
+          <a:p>
+            <a:r>
+              <a:rPr lang="zh-CN" altLang="en-US" dirty="0"/>
+              <a:t>单击此处添加标题</a:t>
+            </a:r>
+            <a:endParaRPr lang="en-US" dirty="0"/>
+          </a:p>
+        </p:txBody>
+      </p:sp>
+      <p:sp>
+        <p:nvSpPr>
+          <p:cNvPr id="5" name="Text Placeholder 5"/>
+          <p:cNvSpPr>
+            <a:spLocks noGrp="1"/>
+          </p:cNvSpPr>
+          <p:nvPr>
+            <p:ph type="body" sz="quarter" idx="10" hasCustomPrompt="1"/>
+          </p:nvPr>
+        </p:nvSpPr>
+        <p:spPr>
+          <a:xfrm>
+            <a:off x="929260" y="1949372"/>
+            <a:ext cx="6535842" cy="643926"/>
+          </a:xfrm>
+        </p:spPr>
+        <p:txBody>
+          <a:bodyPr/>
+          <a:lstStyle>
+            <a:lvl1pPr>
+              <a:defRPr sz="1400">
+                <a:solidFill>
+                  <a:schemeClr val="tx1"/>
+                </a:solidFill>
+              </a:defRPr>
+            </a:lvl1pPr>
+          </a:lstStyle>
+          <a:p>
+            <a:pPr lvl="0"/>
+            <a:r>
+              <a:rPr lang="zh-CN" altLang="en-US" dirty="0"/>
+              <a:t>单击此处添加文本</a:t>
+            </a:r>
+            <a:endParaRPr lang="en-US" dirty="0"/>
+          </a:p>
+        </p:txBody>
+      </p:sp>
+    </p:spTree>
+  </p:cSld>
+  <p:clrMapOvr>
+    <a:masterClrMapping/>
+  </p:clrMapOvr>
+</p:sldLayout>
+</file>
+
+<file path=ppt/slideLayouts/slideLayout3.xml><?xml version="1.0" encoding="utf-8"?>
+<p:sldLayout xmlns:a="http://schemas.openxmlformats.org/drawingml/2006/main" xmlns:r="http://schemas.openxmlformats.org/officeDocument/2006/relationships" xmlns:p="http://schemas.openxmlformats.org/presentationml/2006/main" preserve="1" userDrawn="1">
+  <p:cSld name="攀登">
+    <p:spTree>
+      <p:nvGrpSpPr>
+        <p:cNvPr id="1" name=""/>
+        <p:cNvGrpSpPr/>
+        <p:nvPr/>
+      </p:nvGrpSpPr>
+      <p:grpSpPr>
+        <a:xfrm>
+          <a:off x="0" y="0"/>
+          <a:ext cx="0" cy="0"/>
+          <a:chOff x="0" y="0"/>
+          <a:chExt cx="0" cy="0"/>
+        </a:xfrm>
+      </p:grpSpPr>
+      <p:pic>
+        <p:nvPicPr>
+          <p:cNvPr id="4" name="图片 3"/>
+          <p:cNvPicPr>
+            <a:picLocks noChangeAspect="1"/>
+          </p:cNvPicPr>
+          <p:nvPr userDrawn="1"/>
+        </p:nvPicPr>
+        <p:blipFill rotWithShape="1">
+          <a:blip r:embed="rId2">
+            <a:extLst>
+              <a:ext uri="{28A0092B-C50C-407E-A947-70E740481C1C}">
+                <a14:useLocalDpi xmlns:a14="http://schemas.microsoft.com/office/drawing/2010/main" val="0"/>
+              </a:ext>
+            </a:extLst>
+          </a:blip>
+          <a:srcRect t="13825" r="2034" b="5607"/>
+          <a:stretch>
+            <a:fillRect/>
+          </a:stretch>
+        </p:blipFill>
+        <p:spPr>
+          <a:xfrm>
+            <a:off x="1" y="-36206"/>
+            <a:ext cx="12196763" cy="5638471"/>
+          </a:xfrm>
+          <a:prstGeom prst="rect">
+            <a:avLst/>
+          </a:prstGeom>
+        </p:spPr>
+      </p:pic>
+      <p:sp>
+        <p:nvSpPr>
+          <p:cNvPr id="2" name="Title 1"/>
+          <p:cNvSpPr>
+            <a:spLocks noGrp="1"/>
+          </p:cNvSpPr>
+          <p:nvPr>
+            <p:ph type="ctrTitle" hasCustomPrompt="1"/>
+          </p:nvPr>
+        </p:nvSpPr>
+        <p:spPr>
+          <a:xfrm>
+            <a:off x="898996" y="907092"/>
+            <a:ext cx="6559809" cy="690255"/>
+          </a:xfrm>
+          <a:prstGeom prst="rect">
+            <a:avLst/>
+          </a:prstGeom>
+        </p:spPr>
+        <p:txBody>
+          <a:bodyPr lIns="0" tIns="0" rIns="0" bIns="0" anchor="t">
+            <a:normAutofit/>
+          </a:bodyPr>
+          <a:lstStyle>
+            <a:lvl1pPr algn="l">
+              <a:defRPr sz="3200" b="0" i="0">
+                <a:solidFill>
+                  <a:schemeClr val="tx1"/>
+                </a:solidFill>
+                <a:latin typeface="微软雅黑" panose="020B0503020204020204" pitchFamily="34" charset="-122"/>
+                <a:ea typeface="微软雅黑" panose="020B0503020204020204" pitchFamily="34" charset="-122"/>
+              </a:defRPr>
+            </a:lvl1pPr>
+          </a:lstStyle>
+          <a:p>
+            <a:r>
+              <a:rPr lang="zh-CN" altLang="en-US" dirty="0"/>
+              <a:t>单击此处添加标题</a:t>
+            </a:r>
+            <a:endParaRPr lang="en-US" dirty="0"/>
+          </a:p>
+        </p:txBody>
+      </p:sp>
+      <p:sp>
+        <p:nvSpPr>
+          <p:cNvPr id="8" name="L 形 7"/>
+          <p:cNvSpPr/>
+          <p:nvPr userDrawn="1"/>
+        </p:nvSpPr>
+        <p:spPr>
+          <a:xfrm rot="5400000">
+            <a:off x="7929967" y="1657555"/>
+            <a:ext cx="701032" cy="717936"/>
+          </a:xfrm>
+          <a:prstGeom prst="corner">
+            <a:avLst>
+              <a:gd name="adj1" fmla="val 3243"/>
+              <a:gd name="adj2" fmla="val 3048"/>
+            </a:avLst>
+          </a:prstGeom>
+          <a:solidFill>
+            <a:srgbClr val="C7000B"/>
+          </a:solidFill>
+          <a:ln>
+            <a:noFill/>
+          </a:ln>
+        </p:spPr>
+        <p:style>
+          <a:lnRef idx="2">
+            <a:schemeClr val="accent1">
+              <a:shade val="50000"/>
+            </a:schemeClr>
+          </a:lnRef>
+          <a:fillRef idx="1">
+            <a:schemeClr val="accent1"/>
+          </a:fillRef>
+          <a:effectRef idx="0">
+            <a:schemeClr val="accent1"/>
+          </a:effectRef>
+          <a:fontRef idx="minor">
+            <a:schemeClr val="lt1"/>
+          </a:fontRef>
+        </p:style>
+        <p:txBody>
+          <a:bodyPr rtlCol="0" anchor="ctr"/>
+          <a:lstStyle/>
+          <a:p>
+            <a:pPr algn="ctr"/>
+            <a:endParaRPr kumimoji="1" lang="zh-CN" altLang="en-US" sz="900"/>
+          </a:p>
+        </p:txBody>
+      </p:sp>
+      <p:sp>
+        <p:nvSpPr>
+          <p:cNvPr id="5" name="Text Placeholder 5"/>
+          <p:cNvSpPr>
+            <a:spLocks noGrp="1"/>
+          </p:cNvSpPr>
+          <p:nvPr>
+            <p:ph type="body" sz="quarter" idx="10" hasCustomPrompt="1"/>
+          </p:nvPr>
+        </p:nvSpPr>
+        <p:spPr>
+          <a:xfrm>
+            <a:off x="929260" y="1949372"/>
+            <a:ext cx="6535842" cy="643926"/>
+          </a:xfrm>
+        </p:spPr>
+        <p:txBody>
+          <a:bodyPr/>
+          <a:lstStyle>
+            <a:lvl1pPr>
+              <a:defRPr sz="1400">
+                <a:solidFill>
+                  <a:schemeClr val="tx1"/>
+                </a:solidFill>
+              </a:defRPr>
+            </a:lvl1pPr>
+          </a:lstStyle>
+          <a:p>
+            <a:pPr lvl="0"/>
+            <a:r>
+              <a:rPr lang="zh-CN" altLang="en-US" dirty="0"/>
+              <a:t>单击此处添加文本</a:t>
+            </a:r>
+            <a:endParaRPr lang="en-US" dirty="0"/>
+          </a:p>
+        </p:txBody>
+      </p:sp>
+    </p:spTree>
+  </p:cSld>
+  <p:clrMapOvr>
+    <a:masterClrMapping/>
+  </p:clrMapOvr>
+  <p:timing>
+    <p:tnLst>
+      <p:par>
+        <p:cTn id="1" dur="indefinite" restart="never" nodeType="tmRoot"/>
+      </p:par>
+    </p:tnLst>
+  </p:timing>
+</p:sldLayout>
+</file>
+
+<file path=ppt/slideLayouts/slideLayout4.xml><?xml version="1.0" encoding="utf-8"?>
+<p:sldLayout xmlns:a="http://schemas.openxmlformats.org/drawingml/2006/main" xmlns:r="http://schemas.openxmlformats.org/officeDocument/2006/relationships" xmlns:p="http://schemas.openxmlformats.org/presentationml/2006/main" preserve="1" userDrawn="1">
+  <p:cSld name="灯塔">
+    <p:spTree>
+      <p:nvGrpSpPr>
+        <p:cNvPr id="1" name=""/>
+        <p:cNvGrpSpPr/>
+        <p:nvPr/>
+      </p:nvGrpSpPr>
+      <p:grpSpPr>
+        <a:xfrm>
+          <a:off x="0" y="0"/>
+          <a:ext cx="0" cy="0"/>
+          <a:chOff x="0" y="0"/>
+          <a:chExt cx="0" cy="0"/>
+        </a:xfrm>
+      </p:grpSpPr>
+      <p:pic>
+        <p:nvPicPr>
+          <p:cNvPr id="3" name="图片 2"/>
+          <p:cNvPicPr>
+            <a:picLocks noChangeAspect="1"/>
+          </p:cNvPicPr>
+          <p:nvPr userDrawn="1"/>
+        </p:nvPicPr>
+        <p:blipFill rotWithShape="1">
+          <a:blip r:embed="rId2" cstate="print">
+            <a:extLst>
+              <a:ext uri="{28A0092B-C50C-407E-A947-70E740481C1C}">
+                <a14:useLocalDpi xmlns:a14="http://schemas.microsoft.com/office/drawing/2010/main" val="0"/>
+              </a:ext>
+            </a:extLst>
+          </a:blip>
+          <a:srcRect l="1538" t="7030" b="11599"/>
+          <a:stretch>
+            <a:fillRect/>
+          </a:stretch>
+        </p:blipFill>
+        <p:spPr>
+          <a:xfrm>
+            <a:off x="0" y="0"/>
+            <a:ext cx="12196763" cy="5602265"/>
+          </a:xfrm>
+          <a:prstGeom prst="rect">
+            <a:avLst/>
+          </a:prstGeom>
+        </p:spPr>
+      </p:pic>
+      <p:sp>
+        <p:nvSpPr>
+          <p:cNvPr id="13" name="L 形 12"/>
+          <p:cNvSpPr/>
+          <p:nvPr userDrawn="1"/>
+        </p:nvSpPr>
+        <p:spPr>
+          <a:xfrm rot="5400000">
+            <a:off x="5945516" y="2323519"/>
+            <a:ext cx="701032" cy="717936"/>
+          </a:xfrm>
+          <a:prstGeom prst="corner">
+            <a:avLst>
+              <a:gd name="adj1" fmla="val 3243"/>
+              <a:gd name="adj2" fmla="val 3048"/>
+            </a:avLst>
+          </a:prstGeom>
+          <a:solidFill>
+            <a:srgbClr val="C7000B"/>
+          </a:solidFill>
+          <a:ln>
+            <a:noFill/>
+          </a:ln>
+        </p:spPr>
+        <p:style>
+          <a:lnRef idx="2">
+            <a:schemeClr val="accent1">
+              <a:shade val="50000"/>
+            </a:schemeClr>
+          </a:lnRef>
+          <a:fillRef idx="1">
+            <a:schemeClr val="accent1"/>
+          </a:fillRef>
+          <a:effectRef idx="0">
+            <a:schemeClr val="accent1"/>
+          </a:effectRef>
+          <a:fontRef idx="minor">
+            <a:schemeClr val="lt1"/>
+          </a:fontRef>
+        </p:style>
+        <p:txBody>
+          <a:bodyPr rtlCol="0" anchor="ctr"/>
+          <a:lstStyle/>
+          <a:p>
+            <a:pPr algn="ctr"/>
+            <a:endParaRPr kumimoji="1" lang="zh-CN" altLang="en-US" sz="900"/>
+          </a:p>
+        </p:txBody>
+      </p:sp>
+      <p:sp>
+        <p:nvSpPr>
+          <p:cNvPr id="11" name="Title 1"/>
+          <p:cNvSpPr>
+            <a:spLocks noGrp="1"/>
+          </p:cNvSpPr>
+          <p:nvPr>
+            <p:ph type="ctrTitle" hasCustomPrompt="1"/>
+          </p:nvPr>
+        </p:nvSpPr>
+        <p:spPr>
+          <a:xfrm>
+            <a:off x="898996" y="907092"/>
+            <a:ext cx="6559809" cy="690255"/>
+          </a:xfrm>
+          <a:prstGeom prst="rect">
+            <a:avLst/>
+          </a:prstGeom>
+        </p:spPr>
+        <p:txBody>
+          <a:bodyPr lIns="0" tIns="0" rIns="0" bIns="0" anchor="t">
+            <a:normAutofit/>
+          </a:bodyPr>
+          <a:lstStyle>
+            <a:lvl1pPr algn="l">
+              <a:defRPr sz="3200" b="0" i="0">
+                <a:solidFill>
+                  <a:schemeClr val="tx1"/>
+                </a:solidFill>
+                <a:latin typeface="微软雅黑" panose="020B0503020204020204" pitchFamily="34" charset="-122"/>
+                <a:ea typeface="微软雅黑" panose="020B0503020204020204" pitchFamily="34" charset="-122"/>
+              </a:defRPr>
+            </a:lvl1pPr>
+          </a:lstStyle>
+          <a:p>
+            <a:r>
+              <a:rPr lang="zh-CN" altLang="en-US" dirty="0"/>
+              <a:t>单击此处添加标题</a:t>
+            </a:r>
+            <a:endParaRPr lang="en-US" dirty="0"/>
+          </a:p>
+        </p:txBody>
+      </p:sp>
+      <p:sp>
+        <p:nvSpPr>
+          <p:cNvPr id="5" name="Text Placeholder 5"/>
+          <p:cNvSpPr>
+            <a:spLocks noGrp="1"/>
+          </p:cNvSpPr>
+          <p:nvPr>
+            <p:ph type="body" sz="quarter" idx="10" hasCustomPrompt="1"/>
+          </p:nvPr>
+        </p:nvSpPr>
+        <p:spPr>
+          <a:xfrm>
+            <a:off x="929260" y="1949372"/>
+            <a:ext cx="6535842" cy="643926"/>
+          </a:xfrm>
+        </p:spPr>
+        <p:txBody>
+          <a:bodyPr/>
+          <a:lstStyle>
+            <a:lvl1pPr>
+              <a:defRPr sz="1400">
+                <a:solidFill>
+                  <a:schemeClr val="tx1"/>
+                </a:solidFill>
+              </a:defRPr>
+            </a:lvl1pPr>
+          </a:lstStyle>
+          <a:p>
+            <a:pPr lvl="0"/>
+            <a:r>
+              <a:rPr lang="zh-CN" altLang="en-US" dirty="0"/>
+              <a:t>单击此处添加文本</a:t>
+            </a:r>
+            <a:endParaRPr lang="en-US" dirty="0"/>
+          </a:p>
+        </p:txBody>
+      </p:sp>
+    </p:spTree>
+  </p:cSld>
+  <p:clrMapOvr>
+    <a:masterClrMapping/>
+  </p:clrMapOvr>
+  <p:timing>
+    <p:tnLst>
+      <p:par>
+        <p:cTn id="1" dur="indefinite" restart="never" nodeType="tmRoot"/>
+      </p:par>
+    </p:tnLst>
+  </p:timing>
+</p:sldLayout>
+</file>
+
+<file path=ppt/slideLayouts/slideLayout5.xml><?xml version="1.0" encoding="utf-8"?>
 <p:sldLayout xmlns:a="http://schemas.openxmlformats.org/drawingml/2006/main" xmlns:r="http://schemas.openxmlformats.org/officeDocument/2006/relationships" xmlns:p="http://schemas.openxmlformats.org/presentationml/2006/main" userDrawn="1">
   <p:cSld name="1_Contents page">
     <p:bg>
@@ -1131,7 +1694,7 @@
 </p:sldLayout>
 </file>
 
-<file path=ppt/slideLayouts/slideLayout3.xml><?xml version="1.0" encoding="utf-8"?>
+<file path=ppt/slideLayouts/slideLayout6.xml><?xml version="1.0" encoding="utf-8"?>
 <p:sldLayout xmlns:a="http://schemas.openxmlformats.org/drawingml/2006/main" xmlns:r="http://schemas.openxmlformats.org/officeDocument/2006/relationships" xmlns:p="http://schemas.openxmlformats.org/presentationml/2006/main" userDrawn="1">
   <p:cSld name="1_Chinese text page">
     <p:spTree>
@@ -1324,7 +1887,7 @@
 </p:sldLayout>
 </file>
 
-<file path=ppt/slideLayouts/slideLayout4.xml><?xml version="1.0" encoding="utf-8"?>
+<file path=ppt/slideLayouts/slideLayout7.xml><?xml version="1.0" encoding="utf-8"?>
 <p:sldLayout xmlns:a="http://schemas.openxmlformats.org/drawingml/2006/main" xmlns:r="http://schemas.openxmlformats.org/officeDocument/2006/relationships" xmlns:p="http://schemas.openxmlformats.org/presentationml/2006/main" preserve="1" userDrawn="1">
   <p:cSld name="End page">
     <p:bg>
@@ -1468,7 +2031,7 @@
           <p:nvPr userDrawn="1"/>
         </p:nvPicPr>
         <p:blipFill>
-          <a:blip r:embed="rId2" cstate="print">
+          <a:blip r:embed="rId5" cstate="print">
             <a:extLst>
               <a:ext uri="{28A0092B-C50C-407E-A947-70E740481C1C}">
                 <a14:useLocalDpi xmlns:a14="http://schemas.microsoft.com/office/drawing/2010/main" val="0"/>
@@ -1494,6 +2057,9 @@
   <p:clrMap bg1="lt1" tx1="dk1" bg2="lt2" tx2="dk2" accent1="accent1" accent2="accent2" accent3="accent3" accent4="accent4" accent5="accent5" accent6="accent6" hlink="hlink" folHlink="folHlink"/>
   <p:sldLayoutIdLst>
     <p:sldLayoutId id="2147483649" r:id="rId1"/>
+    <p:sldLayoutId id="2147483650" r:id="rId2"/>
+    <p:sldLayoutId id="2147483651" r:id="rId3"/>
+    <p:sldLayoutId id="2147483652" r:id="rId4"/>
   </p:sldLayoutIdLst>
   <p:timing>
     <p:tnLst>
@@ -1815,7 +2381,7 @@
   </p:cSld>
   <p:clrMap bg1="lt1" tx1="dk1" bg2="lt2" tx2="dk2" accent1="accent1" accent2="accent2" accent3="accent3" accent4="accent4" accent5="accent5" accent6="accent6" hlink="hlink" folHlink="folHlink"/>
   <p:sldLayoutIdLst>
-    <p:sldLayoutId id="2147483651" r:id="rId1"/>
+    <p:sldLayoutId id="2147483654" r:id="rId1"/>
   </p:sldLayoutIdLst>
   <p:hf hdr="0" ftr="0" dt="0"/>
   <p:txStyles>
@@ -4009,7 +4575,7 @@
   </p:cSld>
   <p:clrMap bg1="lt1" tx1="dk1" bg2="lt2" tx2="dk2" accent1="accent1" accent2="accent2" accent3="accent3" accent4="accent4" accent5="accent5" accent6="accent6" hlink="hlink" folHlink="folHlink"/>
   <p:sldLayoutIdLst>
-    <p:sldLayoutId id="2147483653" r:id="rId1"/>
+    <p:sldLayoutId id="2147483656" r:id="rId1"/>
   </p:sldLayoutIdLst>
   <p:timing>
     <p:tnLst>
@@ -5302,7 +5868,7 @@
   </p:cSld>
   <p:clrMap bg1="lt1" tx1="dk1" bg2="lt2" tx2="dk2" accent1="accent1" accent2="accent2" accent3="accent3" accent4="accent4" accent5="accent5" accent6="accent6" hlink="hlink" folHlink="folHlink"/>
   <p:sldLayoutIdLst>
-    <p:sldLayoutId id="2147483655" r:id="rId1"/>
+    <p:sldLayoutId id="2147483658" r:id="rId1"/>
   </p:sldLayoutIdLst>
   <p:hf hdr="0" ftr="0" dt="0"/>
   <p:txStyles>

</xml_diff>